<commit_message>
fix: Day 1 deck and facilitator notes say what competes with what
Slide 11's speaker notes said words on a slide and spoken words "fight
for the same channel"; in Mayer's model it's printed words that compete
with the pictures for learners' eyes, and a few key words are fine. The
slide itself is unchanged. One-day Day 1 deck rebuilt.

Co-Authored-By: Claude Opus 5.5 <noreply@anthropic.com>
Claude-Session: https://claude.ai/code/session_01T23e3au21JYB2q6tbNCUKC
</commit_message>
<xml_diff>
--- a/site/public/slides/tts-day1-death-by-powerpoint.pptx
+++ b/site/public/slides/tts-day1-death-by-powerpoint.pptx
@@ -652,13 +652,13 @@
           <a:p>
             <a:r>
               <a:rPr dirty="0"/>
-              <a:t>  Words on a slide and words from your mouth fight for the same channel. Learners pick one.</a:t>
-            </a:r>
-          </a:p>
-          <a:p>
-            <a:r>
-              <a:rPr dirty="0"/>
-              <a:t>  An image plus your voice uses both.</a:t>
+              <a:t>  A slide full of words pulls learners' eyes away from you, and they read ahead. Learners pick one.</a:t>
+            </a:r>
+          </a:p>
+          <a:p>
+            <a:r>
+              <a:rPr dirty="0"/>
+              <a:t>  An image plus your voice uses eyes and ears together.</a:t>
             </a:r>
           </a:p>
           <a:p>
@@ -676,7 +676,7 @@
           <a:p>
             <a:r>
               <a:rPr dirty="0"/>
-              <a:t>  Dual coding is PAIVIO; the slide-design principles (redundancy, modality) are MAYER's multimedia learning. Not 'always add images': a busy infographic is just more noise. → /theories/dual-coding</a:t>
+              <a:t>  Dual coding is PAIVIO; the slide-design principles (redundancy, modality) are MAYER's multimedia learning. Printed words compete with the pictures for learners' eyes; a few key words are fine. Not 'always add images': a busy infographic is just more noise. → /theories/dual-coding</a:t>
             </a:r>
           </a:p>
           <a:p>

</xml_diff>